<commit_message>
Faster idle scale-down, rerun autoscaler comparison, showcase README
- autoscaler: with work-aware policy, drop straight to MIN_WORKERS after
  IDLE_SCALE_DOWN_S (10 s) with no queued work; new unit test (43 tests)
- rerun HPA / KEDA / work-aware comparison (3 runs each); work-aware now
  uses 25 % fewer pod-seconds than KEDA (was 9 %), 100 % within target;
  old runs kept in benchmark/results/autoscale_before_idle_fix/
- report, slides and guide rebuilt with the new numbers and screenshots
- README rewritten as a project showcase; run steps moved to docs/HOW_TO_RUN.md
- remove superseded v1 report, guide, screenshots, logs and scripts

Co-Authored-By: Claude Opus 5.5 <noreply@anthropic.com>
</commit_message>
<xml_diff>
--- a/docs/Project_Presentation.pptx
+++ b/docs/Project_Presentation.pptx
@@ -1681,13 +1681,13 @@
                 <c:formatCode>General</c:formatCode>
                 <c:ptCount val="3"/>
                 <c:pt idx="0">
-                  <c:v>46.413333333333334</c:v>
+                  <c:v>42.663333333333334</c:v>
                 </c:pt>
                 <c:pt idx="1">
-                  <c:v>10.603333333333333</c:v>
+                  <c:v>14.843333333333334</c:v>
                 </c:pt>
                 <c:pt idx="2">
-                  <c:v>12.303333333333333</c:v>
+                  <c:v>12.506666666666666</c:v>
                 </c:pt>
               </c:numCache>
             </c:numRef>
@@ -1913,7 +1913,7 @@
                 <c:formatCode>General</c:formatCode>
                 <c:ptCount val="3"/>
                 <c:pt idx="0">
-                  <c:v>54.166666666666664</c:v>
+                  <c:v>65.6</c:v>
                 </c:pt>
                 <c:pt idx="1">
                   <c:v>100.0</c:v>
@@ -2145,13 +2145,13 @@
                 <c:formatCode>General</c:formatCode>
                 <c:ptCount val="3"/>
                 <c:pt idx="0">
-                  <c:v>320.5</c:v>
+                  <c:v>327.6333333333333</c:v>
                 </c:pt>
                 <c:pt idx="1">
-                  <c:v>615.9</c:v>
+                  <c:v>656.8000000000001</c:v>
                 </c:pt>
                 <c:pt idx="2">
-                  <c:v>559.5666666666666</c:v>
+                  <c:v>489.9</c:v>
                 </c:pt>
               </c:numCache>
             </c:numRef>
@@ -8218,7 +8218,8 @@
               </a:rPr>
               <a:t>D = latency target 30 s − pod start-up 5 s.
 u = 0.8 target utilisation.
-λ = EMA of the rate at which work arrives.</a:t>
+λ = EMA of the rate at which work arrives.
+Idle (W ≈ 0) for 10 s → drop straight to 1 worker.</a:t>
             </a:r>
           </a:p>
         </p:txBody>
@@ -8688,7 +8689,7 @@
                 </a:solidFill>
                 <a:latin typeface="Calibri"/>
               </a:rPr>
-              <a:t>HPA is cheapest but reacts after 94 s and misses the target. KEDA and work-aware meet it for every job; work-aware uses 9 % fewer pod-seconds because it ignores bursts of cheap tiles (KEDA scales up within 4 s of them), at +1.7 s p95. Next fix: scale down faster after the queue drains.  (Minikube, 8 CPUs; 32 jobs: cheap and expensive bursts; mean of 3 runs each.)</a:t>
+              <a:t>HPA is cheapest but reacts after 78 s and misses the target. KEDA and work-aware meet it for every job; work-aware uses 25 % fewer pod-seconds because it ignores bursts of cheap tiles (KEDA scales up within 4 s of them), with p95 12.5 s vs 14.8 s. Dropping to 1 worker 10 s after the queue empties saves a further ~12 % over our first version.  (Minikube, 8 CPUs; 32 jobs: cheap and expensive bursts; mean of 3 runs each.)</a:t>
             </a:r>
           </a:p>
         </p:txBody>
@@ -9392,7 +9393,7 @@
                 </a:solidFill>
                 <a:latin typeface="Cambria"/>
               </a:rPr>
-              <a:t>42 tests</a:t>
+              <a:t>43 tests</a:t>
             </a:r>
           </a:p>
         </p:txBody>
@@ -9427,7 +9428,7 @@
                 </a:solidFill>
                 <a:latin typeface="Calibri"/>
               </a:rPr>
-              <a:t>all pass · 16 new for the upgrades</a:t>
+              <a:t>all pass · 17 new for the upgrades</a:t>
             </a:r>
           </a:p>
         </p:txBody>

</xml_diff>